<commit_message>
integration: real examples, screenshots, metrics in docs, perf numbers
</commit_message>
<xml_diff>
--- a/docs/presentation/tenderhack_ktru.pptx
+++ b/docs/presentation/tenderhack_ktru.pptx
@@ -1873,6 +1873,10 @@
           </a:solidFill>
           <a:ln/>
         </p:spPr>
+        <p:txBody>
+          <a:bodyPr/>
+          <a:p/>
+        </p:txBody>
       </p:sp>
       <p:sp>
         <p:nvSpPr>
@@ -2201,6 +2205,10 @@
             </a:outerShdw>
           </a:effectLst>
         </p:spPr>
+        <p:txBody>
+          <a:bodyPr/>
+          <a:p/>
+        </p:txBody>
       </p:sp>
       <p:sp>
         <p:nvSpPr>
@@ -2235,7 +2243,7 @@
                 <a:ea typeface="Calibri" pitchFamily="34" charset="-122"/>
                 <a:cs typeface="Calibri" pitchFamily="34" charset="-120"/>
               </a:rPr>
-              <a:t>{{TOP1}}%</a:t>
+              <a:t>92.5%</a:t>
             </a:r>
             <a:endParaRPr lang="en-US" sz="3200" dirty="0"/>
           </a:p>
@@ -2308,6 +2316,10 @@
             </a:outerShdw>
           </a:effectLst>
         </p:spPr>
+        <p:txBody>
+          <a:bodyPr/>
+          <a:p/>
+        </p:txBody>
       </p:sp>
       <p:sp>
         <p:nvSpPr>
@@ -2342,7 +2354,7 @@
                 <a:ea typeface="Calibri" pitchFamily="34" charset="-122"/>
                 <a:cs typeface="Calibri" pitchFamily="34" charset="-120"/>
               </a:rPr>
-              <a:t>{{F1}}%</a:t>
+              <a:t>69.6%</a:t>
             </a:r>
             <a:endParaRPr lang="en-US" sz="3200" dirty="0"/>
           </a:p>
@@ -2415,6 +2427,10 @@
             </a:outerShdw>
           </a:effectLst>
         </p:spPr>
+        <p:txBody>
+          <a:bodyPr/>
+          <a:p/>
+        </p:txBody>
       </p:sp>
       <p:sp>
         <p:nvSpPr>
@@ -2449,7 +2465,7 @@
                 <a:ea typeface="Calibri" pitchFamily="34" charset="-122"/>
                 <a:cs typeface="Calibri" pitchFamily="34" charset="-120"/>
               </a:rPr>
-              <a:t>{{ERR_RECALL}}%</a:t>
+              <a:t>92.8%</a:t>
             </a:r>
             <a:endParaRPr lang="en-US" sz="3200" dirty="0"/>
           </a:p>
@@ -2522,6 +2538,10 @@
             </a:outerShdw>
           </a:effectLst>
         </p:spPr>
+        <p:txBody>
+          <a:bodyPr/>
+          <a:p/>
+        </p:txBody>
       </p:sp>
       <p:sp>
         <p:nvSpPr>
@@ -2556,7 +2576,7 @@
                 <a:ea typeface="Calibri" pitchFamily="34" charset="-122"/>
                 <a:cs typeface="Calibri" pitchFamily="34" charset="-120"/>
               </a:rPr>
-              <a:t>{{P95_MS}} мс</a:t>
+              <a:t>6.4 мс</a:t>
             </a:r>
             <a:endParaRPr lang="en-US" sz="3200" dirty="0"/>
           </a:p>
@@ -2811,6 +2831,10 @@
             </a:outerShdw>
           </a:effectLst>
         </p:spPr>
+        <p:txBody>
+          <a:bodyPr/>
+          <a:p/>
+        </p:txBody>
       </p:sp>
       <p:sp>
         <p:nvSpPr>
@@ -2909,7 +2933,7 @@
                 <a:ea typeface="Calibri" pitchFamily="34" charset="-122"/>
                 <a:cs typeface="Calibri" pitchFamily="34" charset="-120"/>
               </a:rPr>
-              <a:t>&gt;= 50 RPS на реплику</a:t>
+              <a:t>&gt;= 50 RPS на реплику (факт ~570)</a:t>
             </a:r>
             <a:endParaRPr lang="en-US" sz="1600" dirty="0"/>
           </a:p>
@@ -2985,6 +3009,10 @@
             </a:outerShdw>
           </a:effectLst>
         </p:spPr>
+        <p:txBody>
+          <a:bodyPr/>
+          <a:p/>
+        </p:txBody>
       </p:sp>
       <p:sp>
         <p:nvSpPr>
@@ -3266,6 +3294,10 @@
             </a:outerShdw>
           </a:effectLst>
         </p:spPr>
+        <p:txBody>
+          <a:bodyPr/>
+          <a:p/>
+        </p:txBody>
       </p:sp>
       <p:sp>
         <p:nvSpPr>
@@ -3440,6 +3472,10 @@
             </a:outerShdw>
           </a:effectLst>
         </p:spPr>
+        <p:txBody>
+          <a:bodyPr/>
+          <a:p/>
+        </p:txBody>
       </p:sp>
       <p:sp>
         <p:nvSpPr>
@@ -3863,6 +3899,10 @@
             </a:outerShdw>
           </a:effectLst>
         </p:spPr>
+        <p:txBody>
+          <a:bodyPr/>
+          <a:p/>
+        </p:txBody>
       </p:sp>
       <p:sp>
         <p:nvSpPr>
@@ -3970,6 +4010,10 @@
             </a:outerShdw>
           </a:effectLst>
         </p:spPr>
+        <p:txBody>
+          <a:bodyPr/>
+          <a:p/>
+        </p:txBody>
       </p:sp>
       <p:sp>
         <p:nvSpPr>
@@ -4077,6 +4121,10 @@
             </a:outerShdw>
           </a:effectLst>
         </p:spPr>
+        <p:txBody>
+          <a:bodyPr/>
+          <a:p/>
+        </p:txBody>
       </p:sp>
       <p:sp>
         <p:nvSpPr>
@@ -5165,6 +5213,10 @@
             </a:outerShdw>
           </a:effectLst>
         </p:spPr>
+        <p:txBody>
+          <a:bodyPr/>
+          <a:p/>
+        </p:txBody>
       </p:sp>
       <p:sp>
         <p:nvSpPr>
@@ -5185,6 +5237,10 @@
           </a:solidFill>
           <a:ln/>
         </p:spPr>
+        <p:txBody>
+          <a:bodyPr/>
+          <a:p/>
+        </p:txBody>
       </p:sp>
       <p:sp>
         <p:nvSpPr>
@@ -5328,6 +5384,10 @@
             </a:outerShdw>
           </a:effectLst>
         </p:spPr>
+        <p:txBody>
+          <a:bodyPr/>
+          <a:p/>
+        </p:txBody>
       </p:sp>
       <p:sp>
         <p:nvSpPr>
@@ -5348,6 +5408,10 @@
           </a:solidFill>
           <a:ln/>
         </p:spPr>
+        <p:txBody>
+          <a:bodyPr/>
+          <a:p/>
+        </p:txBody>
       </p:sp>
       <p:sp>
         <p:nvSpPr>
@@ -5491,6 +5555,10 @@
             </a:outerShdw>
           </a:effectLst>
         </p:spPr>
+        <p:txBody>
+          <a:bodyPr/>
+          <a:p/>
+        </p:txBody>
       </p:sp>
       <p:sp>
         <p:nvSpPr>
@@ -5511,6 +5579,10 @@
           </a:solidFill>
           <a:ln/>
         </p:spPr>
+        <p:txBody>
+          <a:bodyPr/>
+          <a:p/>
+        </p:txBody>
       </p:sp>
       <p:sp>
         <p:nvSpPr>
@@ -5654,6 +5726,10 @@
             </a:outerShdw>
           </a:effectLst>
         </p:spPr>
+        <p:txBody>
+          <a:bodyPr/>
+          <a:p/>
+        </p:txBody>
       </p:sp>
       <p:sp>
         <p:nvSpPr>
@@ -5674,6 +5750,10 @@
           </a:solidFill>
           <a:ln/>
         </p:spPr>
+        <p:txBody>
+          <a:bodyPr/>
+          <a:p/>
+        </p:txBody>
       </p:sp>
       <p:sp>
         <p:nvSpPr>
@@ -5817,6 +5897,10 @@
             </a:outerShdw>
           </a:effectLst>
         </p:spPr>
+        <p:txBody>
+          <a:bodyPr/>
+          <a:p/>
+        </p:txBody>
       </p:sp>
       <p:sp>
         <p:nvSpPr>
@@ -5837,6 +5921,10 @@
           </a:solidFill>
           <a:ln/>
         </p:spPr>
+        <p:txBody>
+          <a:bodyPr/>
+          <a:p/>
+        </p:txBody>
       </p:sp>
       <p:sp>
         <p:nvSpPr>
@@ -6123,6 +6211,10 @@
             </a:outerShdw>
           </a:effectLst>
         </p:spPr>
+        <p:txBody>
+          <a:bodyPr/>
+          <a:p/>
+        </p:txBody>
       </p:sp>
       <p:sp>
         <p:nvSpPr>
@@ -6230,6 +6322,10 @@
             </a:outerShdw>
           </a:effectLst>
         </p:spPr>
+        <p:txBody>
+          <a:bodyPr/>
+          <a:p/>
+        </p:txBody>
       </p:sp>
       <p:sp>
         <p:nvSpPr>
@@ -6337,6 +6433,10 @@
             </a:outerShdw>
           </a:effectLst>
         </p:spPr>
+        <p:txBody>
+          <a:bodyPr/>
+          <a:p/>
+        </p:txBody>
       </p:sp>
       <p:sp>
         <p:nvSpPr>
@@ -6444,6 +6544,10 @@
             </a:outerShdw>
           </a:effectLst>
         </p:spPr>
+        <p:txBody>
+          <a:bodyPr/>
+          <a:p/>
+        </p:txBody>
       </p:sp>
       <p:sp>
         <p:nvSpPr>
@@ -6551,6 +6655,10 @@
             </a:outerShdw>
           </a:effectLst>
         </p:spPr>
+        <p:txBody>
+          <a:bodyPr/>
+          <a:p/>
+        </p:txBody>
       </p:sp>
       <p:sp>
         <p:nvSpPr>
@@ -6658,6 +6766,10 @@
             </a:outerShdw>
           </a:effectLst>
         </p:spPr>
+        <p:txBody>
+          <a:bodyPr/>
+          <a:p/>
+        </p:txBody>
       </p:sp>
       <p:sp>
         <p:nvSpPr>
@@ -6765,6 +6877,10 @@
             </a:outerShdw>
           </a:effectLst>
         </p:spPr>
+        <p:txBody>
+          <a:bodyPr/>
+          <a:p/>
+        </p:txBody>
       </p:sp>
       <p:sp>
         <p:nvSpPr>
@@ -6872,6 +6988,10 @@
             </a:outerShdw>
           </a:effectLst>
         </p:spPr>
+        <p:txBody>
+          <a:bodyPr/>
+          <a:p/>
+        </p:txBody>
       </p:sp>
       <p:sp>
         <p:nvSpPr>
@@ -6979,6 +7099,10 @@
             </a:outerShdw>
           </a:effectLst>
         </p:spPr>
+        <p:txBody>
+          <a:bodyPr/>
+          <a:p/>
+        </p:txBody>
       </p:sp>
       <p:sp>
         <p:nvSpPr>
@@ -7204,16 +7328,55 @@
           </a:p>
         </p:txBody>
       </p:sp>
+      <p:sp>
+        <p:nvSpPr>
+          <p:cNvPr id="7" name="Text 2"/>
+          <p:cNvSpPr txBox="1"/>
+          <p:nvPr/>
+        </p:nvSpPr>
+        <p:spPr>
+          <a:xfrm>
+            <a:off x="457200" y="4434840"/>
+            <a:ext cx="6949440" cy="457200"/>
+          </a:xfrm>
+          <a:prstGeom prst="rect">
+            <a:avLst/>
+          </a:prstGeom>
+          <a:noFill/>
+          <a:ln/>
+        </p:spPr>
+        <p:txBody>
+          <a:bodyPr wrap="square" lIns="0" tIns="0" rIns="0" bIns="0" rtlCol="0" anchor="t"/>
+          <a:lstStyle/>
+          <a:p>
+            <a:pPr indent="0" marL="0">
+              <a:buNone/>
+            </a:pPr>
+            <a:r>
+              <a:rPr lang="en-US" sz="1200" dirty="0">
+                <a:solidFill>
+                  <a:srgbClr val="6B7280"/>
+                </a:solidFill>
+                <a:latin typeface="Calibri" pitchFamily="34" charset="0"/>
+                <a:ea typeface="Calibri" pitchFamily="34" charset="-122"/>
+                <a:cs typeface="Calibri" pitchFamily="34" charset="-120"/>
+              </a:rPr>
+              <a:t>Код определён · неоднозначно (воронка и рекомендации) · ошибки с подсветкой</a:t>
+            </a:r>
+            <a:endParaRPr lang="en-US" sz="1200" dirty="0"/>
+          </a:p>
+        </p:txBody>
+      </p:sp>
       <p:pic>
         <p:nvPicPr>
-          <p:cNvPr id="4" name="Image 0" descr="ui-resolved">    </p:cNvPr>
+          <p:cNvPr id="8" name="Picture 7" descr="c1.png"/>
           <p:cNvPicPr>
             <a:picLocks noChangeAspect="1"/>
           </p:cNvPicPr>
           <p:nvPr/>
         </p:nvPicPr>
         <p:blipFill>
-          <a:blip r:embed="rId1"/>
+          <a:blip r:embed="rId6"/>
           <a:stretch>
             <a:fillRect/>
           </a:stretch>
@@ -7221,7 +7384,7 @@
         <p:spPr>
           <a:xfrm>
             <a:off x="457200" y="1051560"/>
-            <a:ext cx="2543228" cy="2834640"/>
+            <a:ext cx="2680000" cy="2605555"/>
           </a:xfrm>
           <a:prstGeom prst="rect">
             <a:avLst/>
@@ -7230,22 +7393,22 @@
       </p:pic>
       <p:pic>
         <p:nvPicPr>
-          <p:cNvPr id="5" name="Image 1" descr="ui-ambiguous">    </p:cNvPr>
+          <p:cNvPr id="9" name="Picture 8" descr="c2.png"/>
           <p:cNvPicPr>
             <a:picLocks noChangeAspect="1"/>
           </p:cNvPicPr>
           <p:nvPr/>
         </p:nvPicPr>
         <p:blipFill>
-          <a:blip r:embed="rId2"/>
+          <a:blip r:embed="rId7"/>
           <a:stretch>
             <a:fillRect/>
           </a:stretch>
         </p:blipFill>
         <p:spPr>
           <a:xfrm>
-            <a:off x="3137588" y="1051560"/>
-            <a:ext cx="3014684" cy="2834640"/>
+            <a:off x="3200400" y="1051560"/>
+            <a:ext cx="2680000" cy="2605555"/>
           </a:xfrm>
           <a:prstGeom prst="rect">
             <a:avLst/>
@@ -7254,67 +7417,28 @@
       </p:pic>
       <p:pic>
         <p:nvPicPr>
-          <p:cNvPr id="6" name="Image 2" descr="ui-errors">    </p:cNvPr>
+          <p:cNvPr id="10" name="Picture 9" descr="c3.png"/>
           <p:cNvPicPr>
             <a:picLocks noChangeAspect="1"/>
           </p:cNvPicPr>
           <p:nvPr/>
         </p:nvPicPr>
         <p:blipFill>
-          <a:blip r:embed="rId3"/>
+          <a:blip r:embed="rId8"/>
           <a:stretch>
             <a:fillRect/>
           </a:stretch>
         </p:blipFill>
         <p:spPr>
           <a:xfrm>
-            <a:off x="6289432" y="1051560"/>
-            <a:ext cx="2840558" cy="2834640"/>
+            <a:off x="5943600" y="1051560"/>
+            <a:ext cx="2680000" cy="2605555"/>
           </a:xfrm>
           <a:prstGeom prst="rect">
             <a:avLst/>
           </a:prstGeom>
         </p:spPr>
       </p:pic>
-      <p:sp>
-        <p:nvSpPr>
-          <p:cNvPr id="7" name="Text 2"/>
-          <p:cNvSpPr txBox="1"/>
-          <p:nvPr/>
-        </p:nvSpPr>
-        <p:spPr>
-          <a:xfrm>
-            <a:off x="457200" y="4434840"/>
-            <a:ext cx="6949440" cy="457200"/>
-          </a:xfrm>
-          <a:prstGeom prst="rect">
-            <a:avLst/>
-          </a:prstGeom>
-          <a:noFill/>
-          <a:ln/>
-        </p:spPr>
-        <p:txBody>
-          <a:bodyPr wrap="square" lIns="0" tIns="0" rIns="0" bIns="0" rtlCol="0" anchor="t"/>
-          <a:lstStyle/>
-          <a:p>
-            <a:pPr indent="0" marL="0">
-              <a:buNone/>
-            </a:pPr>
-            <a:r>
-              <a:rPr lang="en-US" sz="1200" dirty="0">
-                <a:solidFill>
-                  <a:srgbClr val="6B7280"/>
-                </a:solidFill>
-                <a:latin typeface="Calibri" pitchFamily="34" charset="0"/>
-                <a:ea typeface="Calibri" pitchFamily="34" charset="-122"/>
-                <a:cs typeface="Calibri" pitchFamily="34" charset="-120"/>
-              </a:rPr>
-              <a:t>Код определён · неоднозначно (воронка и рекомендации) · ошибки с подсветкой</a:t>
-            </a:r>
-            <a:endParaRPr lang="en-US" sz="1200" dirty="0"/>
-          </a:p>
-        </p:txBody>
-      </p:sp>
     </p:spTree>
   </p:cSld>
   <p:clrMapOvr>

</xml_diff>